<commit_message>
Pequenos ajustes na apresentação; exportando .pdf
</commit_message>
<xml_diff>
--- a/lab10/apresentacao/Projeto 10 - Augusto-Guilhereme-Vinicius.pptx
+++ b/lab10/apresentacao/Projeto 10 - Augusto-Guilhereme-Vinicius.pptx
@@ -5,7 +5,7 @@
     <p:sldMasterId id="2147483804" r:id="rId1"/>
   </p:sldMasterIdLst>
   <p:notesMasterIdLst>
-    <p:notesMasterId r:id="rId16"/>
+    <p:notesMasterId r:id="rId17"/>
   </p:notesMasterIdLst>
   <p:sldIdLst>
     <p:sldId id="256" r:id="rId2"/>
@@ -17,11 +17,12 @@
     <p:sldId id="270" r:id="rId8"/>
     <p:sldId id="261" r:id="rId9"/>
     <p:sldId id="262" r:id="rId10"/>
-    <p:sldId id="263" r:id="rId11"/>
-    <p:sldId id="264" r:id="rId12"/>
-    <p:sldId id="265" r:id="rId13"/>
-    <p:sldId id="266" r:id="rId14"/>
-    <p:sldId id="268" r:id="rId15"/>
+    <p:sldId id="272" r:id="rId11"/>
+    <p:sldId id="263" r:id="rId12"/>
+    <p:sldId id="264" r:id="rId13"/>
+    <p:sldId id="265" r:id="rId14"/>
+    <p:sldId id="266" r:id="rId15"/>
+    <p:sldId id="268" r:id="rId16"/>
   </p:sldIdLst>
   <p:sldSz cx="9144000" cy="6858000" type="screen4x3"/>
   <p:notesSz cx="6858000" cy="9144000"/>
@@ -205,7 +206,7 @@
           <a:p>
             <a:fld id="{306A0F26-9B60-4B38-AC42-ED18EBBC8C57}" type="datetimeFigureOut">
               <a:rPr lang="pt-BR" smtClean="0"/>
-              <a:t>20/06/2015</a:t>
+              <a:t>21/06/2015</a:t>
             </a:fld>
             <a:endParaRPr lang="pt-BR"/>
           </a:p>
@@ -557,6 +558,90 @@
 </p:notes>
 </file>
 
+<file path=ppt/notesSlides/notesSlide2.xml><?xml version="1.0" encoding="utf-8"?>
+<p:notes xmlns:a="http://schemas.openxmlformats.org/drawingml/2006/main" xmlns:r="http://schemas.openxmlformats.org/officeDocument/2006/relationships" xmlns:p="http://schemas.openxmlformats.org/presentationml/2006/main">
+  <p:cSld>
+    <p:spTree>
+      <p:nvGrpSpPr>
+        <p:cNvPr id="1" name=""/>
+        <p:cNvGrpSpPr/>
+        <p:nvPr/>
+      </p:nvGrpSpPr>
+      <p:grpSpPr>
+        <a:xfrm>
+          <a:off x="0" y="0"/>
+          <a:ext cx="0" cy="0"/>
+          <a:chOff x="0" y="0"/>
+          <a:chExt cx="0" cy="0"/>
+        </a:xfrm>
+      </p:grpSpPr>
+      <p:sp>
+        <p:nvSpPr>
+          <p:cNvPr id="2" name="Espaço Reservado para Imagem de Slide 1"/>
+          <p:cNvSpPr>
+            <a:spLocks noGrp="1" noRot="1" noChangeAspect="1"/>
+          </p:cNvSpPr>
+          <p:nvPr>
+            <p:ph type="sldImg"/>
+          </p:nvPr>
+        </p:nvSpPr>
+        <p:spPr/>
+      </p:sp>
+      <p:sp>
+        <p:nvSpPr>
+          <p:cNvPr id="3" name="Espaço Reservado para Anotações 2"/>
+          <p:cNvSpPr>
+            <a:spLocks noGrp="1"/>
+          </p:cNvSpPr>
+          <p:nvPr>
+            <p:ph type="body" idx="1"/>
+          </p:nvPr>
+        </p:nvSpPr>
+        <p:spPr/>
+        <p:txBody>
+          <a:bodyPr/>
+          <a:lstStyle/>
+          <a:p>
+            <a:endParaRPr lang="pt-BR" dirty="0"/>
+          </a:p>
+        </p:txBody>
+      </p:sp>
+      <p:sp>
+        <p:nvSpPr>
+          <p:cNvPr id="4" name="Espaço Reservado para Número de Slide 3"/>
+          <p:cNvSpPr>
+            <a:spLocks noGrp="1"/>
+          </p:cNvSpPr>
+          <p:nvPr>
+            <p:ph type="sldNum" sz="quarter" idx="10"/>
+          </p:nvPr>
+        </p:nvSpPr>
+        <p:spPr/>
+        <p:txBody>
+          <a:bodyPr/>
+          <a:lstStyle/>
+          <a:p>
+            <a:fld id="{A92B7A82-F351-430A-9421-B35340673FD6}" type="slidenum">
+              <a:rPr lang="pt-BR" smtClean="0"/>
+              <a:t>10</a:t>
+            </a:fld>
+            <a:endParaRPr lang="pt-BR"/>
+          </a:p>
+        </p:txBody>
+      </p:sp>
+    </p:spTree>
+    <p:extLst>
+      <p:ext uri="{BB962C8B-B14F-4D97-AF65-F5344CB8AC3E}">
+        <p14:creationId xmlns:p14="http://schemas.microsoft.com/office/powerpoint/2010/main" val="690460175"/>
+      </p:ext>
+    </p:extLst>
+  </p:cSld>
+  <p:clrMapOvr>
+    <a:masterClrMapping/>
+  </p:clrMapOvr>
+</p:notes>
+</file>
+
 <file path=ppt/slideLayouts/slideLayout1.xml><?xml version="1.0" encoding="utf-8"?>
 <p:sldLayout xmlns:a="http://schemas.openxmlformats.org/drawingml/2006/main" xmlns:r="http://schemas.openxmlformats.org/officeDocument/2006/relationships" xmlns:p="http://schemas.openxmlformats.org/presentationml/2006/main" showMasterSp="0" type="title" preserve="1">
   <p:cSld name="Slide de título">
@@ -810,7 +895,7 @@
           <a:p>
             <a:fld id="{DCEE50A4-59EC-442D-9CC5-E9AD2F2F923F}" type="datetimeFigureOut">
               <a:rPr lang="pt-BR" smtClean="0"/>
-              <a:t>20/06/2015</a:t>
+              <a:t>21/06/2015</a:t>
             </a:fld>
             <a:endParaRPr lang="pt-BR"/>
           </a:p>
@@ -1023,7 +1108,7 @@
           <a:p>
             <a:fld id="{DCEE50A4-59EC-442D-9CC5-E9AD2F2F923F}" type="datetimeFigureOut">
               <a:rPr lang="pt-BR" smtClean="0"/>
-              <a:t>20/06/2015</a:t>
+              <a:t>21/06/2015</a:t>
             </a:fld>
             <a:endParaRPr lang="pt-BR"/>
           </a:p>
@@ -1290,7 +1375,7 @@
           <a:p>
             <a:fld id="{DCEE50A4-59EC-442D-9CC5-E9AD2F2F923F}" type="datetimeFigureOut">
               <a:rPr lang="pt-BR" smtClean="0"/>
-              <a:t>20/06/2015</a:t>
+              <a:t>21/06/2015</a:t>
             </a:fld>
             <a:endParaRPr lang="pt-BR"/>
           </a:p>
@@ -1440,7 +1525,7 @@
           <a:p>
             <a:fld id="{DCEE50A4-59EC-442D-9CC5-E9AD2F2F923F}" type="datetimeFigureOut">
               <a:rPr lang="pt-BR" smtClean="0"/>
-              <a:t>20/06/2015</a:t>
+              <a:t>21/06/2015</a:t>
             </a:fld>
             <a:endParaRPr lang="pt-BR"/>
           </a:p>
@@ -1770,7 +1855,7 @@
           <a:p>
             <a:fld id="{DCEE50A4-59EC-442D-9CC5-E9AD2F2F923F}" type="datetimeFigureOut">
               <a:rPr lang="pt-BR" smtClean="0"/>
-              <a:t>20/06/2015</a:t>
+              <a:t>21/06/2015</a:t>
             </a:fld>
             <a:endParaRPr lang="pt-BR"/>
           </a:p>
@@ -2078,7 +2163,7 @@
           <a:p>
             <a:fld id="{DCEE50A4-59EC-442D-9CC5-E9AD2F2F923F}" type="datetimeFigureOut">
               <a:rPr lang="pt-BR" smtClean="0"/>
-              <a:t>20/06/2015</a:t>
+              <a:t>21/06/2015</a:t>
             </a:fld>
             <a:endParaRPr lang="pt-BR"/>
           </a:p>
@@ -2499,7 +2584,7 @@
           <a:p>
             <a:fld id="{DCEE50A4-59EC-442D-9CC5-E9AD2F2F923F}" type="datetimeFigureOut">
               <a:rPr lang="pt-BR" smtClean="0"/>
-              <a:t>20/06/2015</a:t>
+              <a:t>21/06/2015</a:t>
             </a:fld>
             <a:endParaRPr lang="pt-BR"/>
           </a:p>
@@ -2612,7 +2697,7 @@
           <a:p>
             <a:fld id="{DCEE50A4-59EC-442D-9CC5-E9AD2F2F923F}" type="datetimeFigureOut">
               <a:rPr lang="pt-BR" smtClean="0"/>
-              <a:t>20/06/2015</a:t>
+              <a:t>21/06/2015</a:t>
             </a:fld>
             <a:endParaRPr lang="pt-BR"/>
           </a:p>
@@ -2771,7 +2856,7 @@
           <a:p>
             <a:fld id="{DCEE50A4-59EC-442D-9CC5-E9AD2F2F923F}" type="datetimeFigureOut">
               <a:rPr lang="pt-BR" smtClean="0"/>
-              <a:t>20/06/2015</a:t>
+              <a:t>21/06/2015</a:t>
             </a:fld>
             <a:endParaRPr lang="pt-BR"/>
           </a:p>
@@ -3155,7 +3240,7 @@
           <a:p>
             <a:fld id="{DCEE50A4-59EC-442D-9CC5-E9AD2F2F923F}" type="datetimeFigureOut">
               <a:rPr lang="pt-BR" smtClean="0"/>
-              <a:t>20/06/2015</a:t>
+              <a:t>21/06/2015</a:t>
             </a:fld>
             <a:endParaRPr lang="pt-BR"/>
           </a:p>
@@ -3517,7 +3602,7 @@
           <a:p>
             <a:fld id="{DCEE50A4-59EC-442D-9CC5-E9AD2F2F923F}" type="datetimeFigureOut">
               <a:rPr lang="pt-BR" smtClean="0"/>
-              <a:t>20/06/2015</a:t>
+              <a:t>21/06/2015</a:t>
             </a:fld>
             <a:endParaRPr lang="pt-BR"/>
           </a:p>
@@ -3851,7 +3936,7 @@
           <a:p>
             <a:fld id="{DCEE50A4-59EC-442D-9CC5-E9AD2F2F923F}" type="datetimeFigureOut">
               <a:rPr lang="pt-BR" smtClean="0"/>
-              <a:t>20/06/2015</a:t>
+              <a:t>21/06/2015</a:t>
             </a:fld>
             <a:endParaRPr lang="pt-BR"/>
           </a:p>
@@ -4380,6 +4465,325 @@
           <a:p>
             <a:r>
               <a:rPr lang="pt-BR" dirty="0" smtClean="0"/>
+              <a:t>Controle PI pelo </a:t>
+            </a:r>
+            <a:r>
+              <a:rPr lang="pt-BR" dirty="0" err="1" smtClean="0"/>
+              <a:t>Sisotool</a:t>
+            </a:r>
+            <a:endParaRPr lang="pt-BR" dirty="0"/>
+          </a:p>
+        </p:txBody>
+      </p:sp>
+      <p:sp>
+        <p:nvSpPr>
+          <p:cNvPr id="3" name="Título 2"/>
+          <p:cNvSpPr>
+            <a:spLocks noGrp="1"/>
+          </p:cNvSpPr>
+          <p:nvPr>
+            <p:ph type="title"/>
+          </p:nvPr>
+        </p:nvSpPr>
+        <p:spPr/>
+        <p:txBody>
+          <a:bodyPr/>
+          <a:lstStyle/>
+          <a:p>
+            <a:pPr algn="l"/>
+            <a:r>
+              <a:rPr lang="pt-BR" dirty="0"/>
+              <a:t>Controle Planta teórica</a:t>
+            </a:r>
+          </a:p>
+        </p:txBody>
+      </p:sp>
+      <p:pic>
+        <p:nvPicPr>
+          <p:cNvPr id="5122" name="Picture 2" descr="C:\Users\Vinícius\Desktop\Graduacao\9 semestre\ES828\LabControle\lab10\controlador_sisotool.png"/>
+          <p:cNvPicPr>
+            <a:picLocks noChangeAspect="1" noChangeArrowheads="1"/>
+          </p:cNvPicPr>
+          <p:nvPr/>
+        </p:nvPicPr>
+        <p:blipFill>
+          <a:blip r:embed="rId3">
+            <a:extLst>
+              <a:ext uri="{28A0092B-C50C-407E-A947-70E740481C1C}">
+                <a14:useLocalDpi xmlns:a14="http://schemas.microsoft.com/office/drawing/2010/main" val="0"/>
+              </a:ext>
+            </a:extLst>
+          </a:blip>
+          <a:srcRect/>
+          <a:stretch>
+            <a:fillRect/>
+          </a:stretch>
+        </p:blipFill>
+        <p:spPr bwMode="auto">
+          <a:xfrm>
+            <a:off x="323410" y="2286919"/>
+            <a:ext cx="4173756" cy="4022481"/>
+          </a:xfrm>
+          <a:prstGeom prst="rect">
+            <a:avLst/>
+          </a:prstGeom>
+          <a:noFill/>
+          <a:extLst>
+            <a:ext uri="{909E8E84-426E-40DD-AFC4-6F175D3DCCD1}">
+              <a14:hiddenFill xmlns:a14="http://schemas.microsoft.com/office/drawing/2010/main">
+                <a:solidFill>
+                  <a:srgbClr val="FFFFFF"/>
+                </a:solidFill>
+              </a14:hiddenFill>
+            </a:ext>
+          </a:extLst>
+        </p:spPr>
+      </p:pic>
+      <p:pic>
+        <p:nvPicPr>
+          <p:cNvPr id="5124" name="Picture 4" descr="C:\Users\Vinícius\Desktop\Graduacao\9 semestre\ES828\LabControle\lab10\saidas_sisotool.png"/>
+          <p:cNvPicPr>
+            <a:picLocks noChangeAspect="1" noChangeArrowheads="1"/>
+          </p:cNvPicPr>
+          <p:nvPr/>
+        </p:nvPicPr>
+        <p:blipFill>
+          <a:blip r:embed="rId4">
+            <a:extLst>
+              <a:ext uri="{28A0092B-C50C-407E-A947-70E740481C1C}">
+                <a14:useLocalDpi xmlns:a14="http://schemas.microsoft.com/office/drawing/2010/main" val="0"/>
+              </a:ext>
+            </a:extLst>
+          </a:blip>
+          <a:srcRect/>
+          <a:stretch>
+            <a:fillRect/>
+          </a:stretch>
+        </p:blipFill>
+        <p:spPr bwMode="auto">
+          <a:xfrm>
+            <a:off x="4707189" y="2286919"/>
+            <a:ext cx="4153818" cy="4022481"/>
+          </a:xfrm>
+          <a:prstGeom prst="rect">
+            <a:avLst/>
+          </a:prstGeom>
+          <a:noFill/>
+          <a:extLst>
+            <a:ext uri="{909E8E84-426E-40DD-AFC4-6F175D3DCCD1}">
+              <a14:hiddenFill xmlns:a14="http://schemas.microsoft.com/office/drawing/2010/main">
+                <a:solidFill>
+                  <a:srgbClr val="FFFFFF"/>
+                </a:solidFill>
+              </a14:hiddenFill>
+            </a:ext>
+          </a:extLst>
+        </p:spPr>
+      </p:pic>
+      <mc:AlternateContent xmlns:mc="http://schemas.openxmlformats.org/markup-compatibility/2006">
+        <mc:Choice xmlns:a14="http://schemas.microsoft.com/office/drawing/2010/main" Requires="a14">
+          <p:sp>
+            <p:nvSpPr>
+              <p:cNvPr id="6" name="CaixaDeTexto 5"/>
+              <p:cNvSpPr txBox="1"/>
+              <p:nvPr/>
+            </p:nvSpPr>
+            <p:spPr>
+              <a:xfrm>
+                <a:off x="5780111" y="1628750"/>
+                <a:ext cx="2320379" cy="612796"/>
+              </a:xfrm>
+              <a:prstGeom prst="rect">
+                <a:avLst/>
+              </a:prstGeom>
+              <a:noFill/>
+            </p:spPr>
+            <p:txBody>
+              <a:bodyPr wrap="none" rtlCol="0">
+                <a:spAutoFit/>
+              </a:bodyPr>
+              <a:lstStyle/>
+              <a:p>
+                <a14:m>
+                  <m:oMathPara xmlns:m="http://schemas.openxmlformats.org/officeDocument/2006/math">
+                    <m:oMathParaPr>
+                      <m:jc m:val="centerGroup"/>
+                    </m:oMathParaPr>
+                    <m:oMath xmlns:m="http://schemas.openxmlformats.org/officeDocument/2006/math">
+                      <m:sSub>
+                        <m:sSubPr>
+                          <m:ctrlPr>
+                            <a:rPr lang="en-US" b="0" i="1" smtClean="0">
+                              <a:latin typeface="Cambria Math"/>
+                            </a:rPr>
+                          </m:ctrlPr>
+                        </m:sSubPr>
+                        <m:e>
+                          <m:r>
+                            <a:rPr lang="en-US" b="0" i="1" smtClean="0">
+                              <a:latin typeface="Cambria Math"/>
+                            </a:rPr>
+                            <m:t>𝐶</m:t>
+                          </m:r>
+                        </m:e>
+                        <m:sub>
+                          <m:r>
+                            <a:rPr lang="en-US" b="0" i="1" smtClean="0">
+                              <a:latin typeface="Cambria Math"/>
+                            </a:rPr>
+                            <m:t>𝑠𝑖𝑠𝑜</m:t>
+                          </m:r>
+                        </m:sub>
+                      </m:sSub>
+                      <m:d>
+                        <m:dPr>
+                          <m:ctrlPr>
+                            <a:rPr lang="en-US" b="0" i="1" smtClean="0">
+                              <a:latin typeface="Cambria Math"/>
+                            </a:rPr>
+                          </m:ctrlPr>
+                        </m:dPr>
+                        <m:e>
+                          <m:r>
+                            <a:rPr lang="en-US" b="0" i="1" smtClean="0">
+                              <a:latin typeface="Cambria Math"/>
+                            </a:rPr>
+                            <m:t>𝑠</m:t>
+                          </m:r>
+                        </m:e>
+                      </m:d>
+                      <m:r>
+                        <a:rPr lang="en-US" b="0" i="1" smtClean="0">
+                          <a:latin typeface="Cambria Math"/>
+                        </a:rPr>
+                        <m:t>=1.1+</m:t>
+                      </m:r>
+                      <m:f>
+                        <m:fPr>
+                          <m:ctrlPr>
+                            <a:rPr lang="en-US" b="0" i="1" smtClean="0">
+                              <a:latin typeface="Cambria Math"/>
+                            </a:rPr>
+                          </m:ctrlPr>
+                        </m:fPr>
+                        <m:num>
+                          <m:r>
+                            <a:rPr lang="en-US" b="0" i="1" smtClean="0">
+                              <a:latin typeface="Cambria Math"/>
+                            </a:rPr>
+                            <m:t>11.6</m:t>
+                          </m:r>
+                        </m:num>
+                        <m:den>
+                          <m:r>
+                            <a:rPr lang="en-US" b="0" i="1" smtClean="0">
+                              <a:latin typeface="Cambria Math"/>
+                            </a:rPr>
+                            <m:t>𝑠</m:t>
+                          </m:r>
+                        </m:den>
+                      </m:f>
+                    </m:oMath>
+                  </m:oMathPara>
+                </a14:m>
+                <a:endParaRPr lang="pt-BR" dirty="0"/>
+              </a:p>
+            </p:txBody>
+          </p:sp>
+        </mc:Choice>
+        <mc:Fallback>
+          <p:sp>
+            <p:nvSpPr>
+              <p:cNvPr id="6" name="CaixaDeTexto 5"/>
+              <p:cNvSpPr txBox="1">
+                <a:spLocks noRot="1" noChangeAspect="1" noMove="1" noResize="1" noEditPoints="1" noAdjustHandles="1" noChangeArrowheads="1" noChangeShapeType="1" noTextEdit="1"/>
+              </p:cNvSpPr>
+              <p:nvPr/>
+            </p:nvSpPr>
+            <p:spPr>
+              <a:xfrm>
+                <a:off x="5780111" y="1628750"/>
+                <a:ext cx="2320379" cy="612796"/>
+              </a:xfrm>
+              <a:prstGeom prst="rect">
+                <a:avLst/>
+              </a:prstGeom>
+              <a:blipFill rotWithShape="1">
+                <a:blip r:embed="rId5"/>
+                <a:stretch>
+                  <a:fillRect r="-3150"/>
+                </a:stretch>
+              </a:blipFill>
+            </p:spPr>
+            <p:txBody>
+              <a:bodyPr/>
+              <a:lstStyle/>
+              <a:p>
+                <a:r>
+                  <a:rPr lang="pt-BR">
+                    <a:noFill/>
+                  </a:rPr>
+                  <a:t> </a:t>
+                </a:r>
+              </a:p>
+            </p:txBody>
+          </p:sp>
+        </mc:Fallback>
+      </mc:AlternateContent>
+    </p:spTree>
+    <p:extLst>
+      <p:ext uri="{BB962C8B-B14F-4D97-AF65-F5344CB8AC3E}">
+        <p14:creationId xmlns:p14="http://schemas.microsoft.com/office/powerpoint/2010/main" val="2922463264"/>
+      </p:ext>
+    </p:extLst>
+  </p:cSld>
+  <p:clrMapOvr>
+    <a:masterClrMapping/>
+  </p:clrMapOvr>
+  <p:timing>
+    <p:tnLst>
+      <p:par>
+        <p:cTn id="1" dur="indefinite" restart="never" nodeType="tmRoot"/>
+      </p:par>
+    </p:tnLst>
+  </p:timing>
+</p:sld>
+</file>
+
+<file path=ppt/slides/slide11.xml><?xml version="1.0" encoding="utf-8"?>
+<p:sld xmlns:a="http://schemas.openxmlformats.org/drawingml/2006/main" xmlns:r="http://schemas.openxmlformats.org/officeDocument/2006/relationships" xmlns:p="http://schemas.openxmlformats.org/presentationml/2006/main">
+  <p:cSld>
+    <p:spTree>
+      <p:nvGrpSpPr>
+        <p:cNvPr id="1" name=""/>
+        <p:cNvGrpSpPr/>
+        <p:nvPr/>
+      </p:nvGrpSpPr>
+      <p:grpSpPr>
+        <a:xfrm>
+          <a:off x="0" y="0"/>
+          <a:ext cx="0" cy="0"/>
+          <a:chOff x="0" y="0"/>
+          <a:chExt cx="0" cy="0"/>
+        </a:xfrm>
+      </p:grpSpPr>
+      <p:sp>
+        <p:nvSpPr>
+          <p:cNvPr id="2" name="Espaço Reservado para Conteúdo 1"/>
+          <p:cNvSpPr>
+            <a:spLocks noGrp="1"/>
+          </p:cNvSpPr>
+          <p:nvPr>
+            <p:ph idx="1"/>
+          </p:nvPr>
+        </p:nvSpPr>
+        <p:spPr/>
+        <p:txBody>
+          <a:bodyPr/>
+          <a:lstStyle/>
+          <a:p>
+            <a:r>
+              <a:rPr lang="pt-BR" dirty="0" smtClean="0"/>
               <a:t>Resultado prático</a:t>
             </a:r>
             <a:endParaRPr lang="pt-BR" dirty="0"/>
@@ -4564,7 +4968,7 @@
 </p:sld>
 </file>
 
-<file path=ppt/slides/slide11.xml><?xml version="1.0" encoding="utf-8"?>
+<file path=ppt/slides/slide12.xml><?xml version="1.0" encoding="utf-8"?>
 <p:sld xmlns:a="http://schemas.openxmlformats.org/drawingml/2006/main" xmlns:r="http://schemas.openxmlformats.org/officeDocument/2006/relationships" xmlns:p="http://schemas.openxmlformats.org/presentationml/2006/main">
   <p:cSld>
     <p:spTree>
@@ -4581,25 +4985,6 @@
           <a:chExt cx="0" cy="0"/>
         </a:xfrm>
       </p:grpSpPr>
-      <p:sp>
-        <p:nvSpPr>
-          <p:cNvPr id="2" name="Espaço Reservado para Conteúdo 1"/>
-          <p:cNvSpPr>
-            <a:spLocks noGrp="1"/>
-          </p:cNvSpPr>
-          <p:nvPr>
-            <p:ph idx="1"/>
-          </p:nvPr>
-        </p:nvSpPr>
-        <p:spPr/>
-        <p:txBody>
-          <a:bodyPr/>
-          <a:lstStyle/>
-          <a:p>
-            <a:endParaRPr lang="pt-BR" dirty="0"/>
-          </a:p>
-        </p:txBody>
-      </p:sp>
       <p:sp>
         <p:nvSpPr>
           <p:cNvPr id="3" name="Título 2"/>
@@ -4770,7 +5155,7 @@
 </p:sld>
 </file>
 
-<file path=ppt/slides/slide12.xml><?xml version="1.0" encoding="utf-8"?>
+<file path=ppt/slides/slide13.xml><?xml version="1.0" encoding="utf-8"?>
 <p:sld xmlns:a="http://schemas.openxmlformats.org/drawingml/2006/main" xmlns:r="http://schemas.openxmlformats.org/officeDocument/2006/relationships" xmlns:p="http://schemas.openxmlformats.org/presentationml/2006/main">
   <p:cSld>
     <p:spTree>
@@ -4787,25 +5172,6 @@
           <a:chExt cx="0" cy="0"/>
         </a:xfrm>
       </p:grpSpPr>
-      <p:sp>
-        <p:nvSpPr>
-          <p:cNvPr id="2" name="Espaço Reservado para Conteúdo 1"/>
-          <p:cNvSpPr>
-            <a:spLocks noGrp="1"/>
-          </p:cNvSpPr>
-          <p:nvPr>
-            <p:ph idx="1"/>
-          </p:nvPr>
-        </p:nvSpPr>
-        <p:spPr/>
-        <p:txBody>
-          <a:bodyPr/>
-          <a:lstStyle/>
-          <a:p>
-            <a:endParaRPr lang="pt-BR" dirty="0"/>
-          </a:p>
-        </p:txBody>
-      </p:sp>
       <p:sp>
         <p:nvSpPr>
           <p:cNvPr id="3" name="Título 2"/>
@@ -4853,7 +5219,7 @@
         </p:blipFill>
         <p:spPr bwMode="auto">
           <a:xfrm>
-            <a:off x="1907704" y="1700808"/>
+            <a:off x="395420" y="1700808"/>
             <a:ext cx="5334000" cy="4000500"/>
           </a:xfrm>
           <a:prstGeom prst="rect">
@@ -4929,6 +5295,156 @@
           </a:p>
         </p:txBody>
       </p:sp>
+      <mc:AlternateContent xmlns:mc="http://schemas.openxmlformats.org/markup-compatibility/2006">
+        <mc:Choice xmlns:a14="http://schemas.microsoft.com/office/drawing/2010/main" Requires="a14">
+          <p:sp>
+            <p:nvSpPr>
+              <p:cNvPr id="4" name="CaixaDeTexto 3"/>
+              <p:cNvSpPr txBox="1"/>
+              <p:nvPr/>
+            </p:nvSpPr>
+            <p:spPr>
+              <a:xfrm>
+                <a:off x="6084210" y="3394660"/>
+                <a:ext cx="2169440" cy="612796"/>
+              </a:xfrm>
+              <a:prstGeom prst="rect">
+                <a:avLst/>
+              </a:prstGeom>
+              <a:noFill/>
+            </p:spPr>
+            <p:txBody>
+              <a:bodyPr wrap="none" rtlCol="0">
+                <a:spAutoFit/>
+              </a:bodyPr>
+              <a:lstStyle/>
+              <a:p>
+                <a14:m>
+                  <m:oMathPara xmlns:m="http://schemas.openxmlformats.org/officeDocument/2006/math">
+                    <m:oMathParaPr>
+                      <m:jc m:val="centerGroup"/>
+                    </m:oMathParaPr>
+                    <m:oMath xmlns:m="http://schemas.openxmlformats.org/officeDocument/2006/math">
+                      <m:sSub>
+                        <m:sSubPr>
+                          <m:ctrlPr>
+                            <a:rPr lang="en-US" b="0" i="1" smtClean="0">
+                              <a:latin typeface="Cambria Math"/>
+                            </a:rPr>
+                          </m:ctrlPr>
+                        </m:sSubPr>
+                        <m:e>
+                          <m:r>
+                            <a:rPr lang="en-US" b="0" i="1" smtClean="0">
+                              <a:latin typeface="Cambria Math"/>
+                            </a:rPr>
+                            <m:t>𝐶</m:t>
+                          </m:r>
+                        </m:e>
+                        <m:sub>
+                          <m:r>
+                            <a:rPr lang="en-US" b="0" i="1" smtClean="0">
+                              <a:latin typeface="Cambria Math"/>
+                            </a:rPr>
+                            <m:t>𝑣𝑒𝑟𝑑𝑒</m:t>
+                          </m:r>
+                        </m:sub>
+                      </m:sSub>
+                      <m:d>
+                        <m:dPr>
+                          <m:ctrlPr>
+                            <a:rPr lang="en-US" b="0" i="1" smtClean="0">
+                              <a:latin typeface="Cambria Math"/>
+                            </a:rPr>
+                          </m:ctrlPr>
+                        </m:dPr>
+                        <m:e>
+                          <m:r>
+                            <a:rPr lang="en-US" b="0" i="1" smtClean="0">
+                              <a:latin typeface="Cambria Math"/>
+                            </a:rPr>
+                            <m:t>𝑠</m:t>
+                          </m:r>
+                        </m:e>
+                      </m:d>
+                      <m:r>
+                        <a:rPr lang="en-US" b="0" i="1" smtClean="0">
+                          <a:latin typeface="Cambria Math"/>
+                        </a:rPr>
+                        <m:t>=2+</m:t>
+                      </m:r>
+                      <m:f>
+                        <m:fPr>
+                          <m:ctrlPr>
+                            <a:rPr lang="en-US" b="0" i="1" smtClean="0">
+                              <a:latin typeface="Cambria Math"/>
+                            </a:rPr>
+                          </m:ctrlPr>
+                        </m:fPr>
+                        <m:num>
+                          <m:r>
+                            <a:rPr lang="en-US" b="0" i="1" smtClean="0">
+                              <a:latin typeface="Cambria Math"/>
+                            </a:rPr>
+                            <m:t>0.1</m:t>
+                          </m:r>
+                        </m:num>
+                        <m:den>
+                          <m:r>
+                            <a:rPr lang="en-US" b="0" i="1" smtClean="0">
+                              <a:latin typeface="Cambria Math"/>
+                            </a:rPr>
+                            <m:t>𝑠</m:t>
+                          </m:r>
+                        </m:den>
+                      </m:f>
+                    </m:oMath>
+                  </m:oMathPara>
+                </a14:m>
+                <a:endParaRPr lang="pt-BR" dirty="0"/>
+              </a:p>
+            </p:txBody>
+          </p:sp>
+        </mc:Choice>
+        <mc:Fallback>
+          <p:sp>
+            <p:nvSpPr>
+              <p:cNvPr id="4" name="CaixaDeTexto 3"/>
+              <p:cNvSpPr txBox="1">
+                <a:spLocks noRot="1" noChangeAspect="1" noMove="1" noResize="1" noEditPoints="1" noAdjustHandles="1" noChangeArrowheads="1" noChangeShapeType="1" noTextEdit="1"/>
+              </p:cNvSpPr>
+              <p:nvPr/>
+            </p:nvSpPr>
+            <p:spPr>
+              <a:xfrm>
+                <a:off x="6084210" y="3394660"/>
+                <a:ext cx="2169440" cy="612796"/>
+              </a:xfrm>
+              <a:prstGeom prst="rect">
+                <a:avLst/>
+              </a:prstGeom>
+              <a:blipFill rotWithShape="1">
+                <a:blip r:embed="rId3"/>
+                <a:stretch>
+                  <a:fillRect r="-3371"/>
+                </a:stretch>
+              </a:blipFill>
+            </p:spPr>
+            <p:txBody>
+              <a:bodyPr/>
+              <a:lstStyle/>
+              <a:p>
+                <a:r>
+                  <a:rPr lang="pt-BR">
+                    <a:noFill/>
+                  </a:rPr>
+                  <a:t> </a:t>
+                </a:r>
+              </a:p>
+            </p:txBody>
+          </p:sp>
+        </mc:Fallback>
+      </mc:AlternateContent>
     </p:spTree>
     <p:extLst>
       <p:ext uri="{BB962C8B-B14F-4D97-AF65-F5344CB8AC3E}">
@@ -4949,7 +5465,7 @@
 </p:sld>
 </file>
 
-<file path=ppt/slides/slide13.xml><?xml version="1.0" encoding="utf-8"?>
+<file path=ppt/slides/slide14.xml><?xml version="1.0" encoding="utf-8"?>
 <p:sld xmlns:a="http://schemas.openxmlformats.org/drawingml/2006/main" xmlns:r="http://schemas.openxmlformats.org/officeDocument/2006/relationships" xmlns:p="http://schemas.openxmlformats.org/presentationml/2006/main">
   <p:cSld>
     <p:spTree>
@@ -4966,25 +5482,6 @@
           <a:chExt cx="0" cy="0"/>
         </a:xfrm>
       </p:grpSpPr>
-      <p:sp>
-        <p:nvSpPr>
-          <p:cNvPr id="2" name="Espaço Reservado para Conteúdo 1"/>
-          <p:cNvSpPr>
-            <a:spLocks noGrp="1"/>
-          </p:cNvSpPr>
-          <p:nvPr>
-            <p:ph idx="1"/>
-          </p:nvPr>
-        </p:nvSpPr>
-        <p:spPr/>
-        <p:txBody>
-          <a:bodyPr/>
-          <a:lstStyle/>
-          <a:p>
-            <a:endParaRPr lang="pt-BR"/>
-          </a:p>
-        </p:txBody>
-      </p:sp>
       <p:sp>
         <p:nvSpPr>
           <p:cNvPr id="3" name="Título 2"/>
@@ -5031,7 +5528,7 @@
         </p:blipFill>
         <p:spPr bwMode="auto">
           <a:xfrm>
-            <a:off x="1907704" y="1700808"/>
+            <a:off x="395420" y="1700808"/>
             <a:ext cx="5334000" cy="4000500"/>
           </a:xfrm>
           <a:prstGeom prst="rect">
@@ -5087,7 +5584,11 @@
             <a:pPr algn="ctr"/>
             <a:r>
               <a:rPr lang="pt-BR" dirty="0" smtClean="0"/>
-              <a:t>Sinal de controle satura até 6s</a:t>
+              <a:t>Sinal de controle </a:t>
+            </a:r>
+            <a:r>
+              <a:rPr lang="pt-BR" dirty="0" smtClean="0"/>
+              <a:t>satura nos 6s iniciais</a:t>
             </a:r>
             <a:endParaRPr lang="pt-BR" dirty="0"/>
           </a:p>
@@ -5113,7 +5614,7 @@
 </p:sld>
 </file>
 
-<file path=ppt/slides/slide14.xml><?xml version="1.0" encoding="utf-8"?>
+<file path=ppt/slides/slide15.xml><?xml version="1.0" encoding="utf-8"?>
 <p:sld xmlns:a="http://schemas.openxmlformats.org/drawingml/2006/main" xmlns:r="http://schemas.openxmlformats.org/officeDocument/2006/relationships" xmlns:p="http://schemas.openxmlformats.org/presentationml/2006/main">
   <p:cSld>
     <p:spTree>
@@ -5376,25 +5877,6 @@
       </p:grpSpPr>
       <p:sp>
         <p:nvSpPr>
-          <p:cNvPr id="2" name="Espaço Reservado para Conteúdo 1"/>
-          <p:cNvSpPr>
-            <a:spLocks noGrp="1"/>
-          </p:cNvSpPr>
-          <p:nvPr>
-            <p:ph idx="1"/>
-          </p:nvPr>
-        </p:nvSpPr>
-        <p:spPr/>
-        <p:txBody>
-          <a:bodyPr/>
-          <a:lstStyle/>
-          <a:p>
-            <a:endParaRPr lang="pt-BR"/>
-          </a:p>
-        </p:txBody>
-      </p:sp>
-      <p:sp>
-        <p:nvSpPr>
           <p:cNvPr id="3" name="Título 2"/>
           <p:cNvSpPr>
             <a:spLocks noGrp="1"/>
@@ -5507,6 +5989,13 @@
   <p:clrMapOvr>
     <a:masterClrMapping/>
   </p:clrMapOvr>
+  <p:timing>
+    <p:tnLst>
+      <p:par>
+        <p:cTn id="1" dur="indefinite" restart="never" nodeType="tmRoot"/>
+      </p:par>
+    </p:tnLst>
+  </p:timing>
 </p:sld>
 </file>
 
@@ -7314,28 +7803,6 @@
       </p:grpSpPr>
       <p:sp>
         <p:nvSpPr>
-          <p:cNvPr id="2" name="Espaço Reservado para Conteúdo 1"/>
-          <p:cNvSpPr>
-            <a:spLocks noGrp="1"/>
-          </p:cNvSpPr>
-          <p:nvPr>
-            <p:ph idx="1"/>
-          </p:nvPr>
-        </p:nvSpPr>
-        <p:spPr/>
-        <p:txBody>
-          <a:bodyPr/>
-          <a:lstStyle/>
-          <a:p>
-            <a:pPr marL="45720" indent="0">
-              <a:buNone/>
-            </a:pPr>
-            <a:endParaRPr lang="pt-BR" dirty="0"/>
-          </a:p>
-        </p:txBody>
-      </p:sp>
-      <p:sp>
-        <p:nvSpPr>
           <p:cNvPr id="3" name="Título 2"/>
           <p:cNvSpPr>
             <a:spLocks noGrp="1"/>
@@ -7497,11 +7964,7 @@
           <a:p>
             <a:r>
               <a:rPr lang="pt-BR" dirty="0" smtClean="0"/>
-              <a:t>Controle PI pelo </a:t>
-            </a:r>
-            <a:r>
-              <a:rPr lang="pt-BR" dirty="0" err="1" smtClean="0"/>
-              <a:t>Sisotool</a:t>
+              <a:t>Controlador PI</a:t>
             </a:r>
             <a:endParaRPr lang="pt-BR" dirty="0"/>
           </a:p>
@@ -7524,94 +7987,381 @@
           <a:p>
             <a:pPr algn="l"/>
             <a:r>
-              <a:rPr lang="pt-BR" dirty="0"/>
-              <a:t>Controle Planta teórica</a:t>
-            </a:r>
-          </a:p>
-        </p:txBody>
-      </p:sp>
-      <p:pic>
-        <p:nvPicPr>
-          <p:cNvPr id="5122" name="Picture 2" descr="C:\Users\Vinícius\Desktop\Graduacao\9 semestre\ES828\LabControle\lab10\controlador_sisotool.png"/>
-          <p:cNvPicPr>
-            <a:picLocks noChangeAspect="1" noChangeArrowheads="1"/>
-          </p:cNvPicPr>
+              <a:rPr lang="pt-BR" dirty="0" smtClean="0"/>
+              <a:t>Estrutura do controlador</a:t>
+            </a:r>
+            <a:endParaRPr lang="pt-BR" dirty="0"/>
+          </a:p>
+        </p:txBody>
+      </p:sp>
+      <mc:AlternateContent xmlns:mc="http://schemas.openxmlformats.org/markup-compatibility/2006">
+        <mc:Choice xmlns:a14="http://schemas.microsoft.com/office/drawing/2010/main" Requires="a14">
+          <p:sp>
+            <p:nvSpPr>
+              <p:cNvPr id="4" name="CaixaDeTexto 3"/>
+              <p:cNvSpPr txBox="1"/>
+              <p:nvPr/>
+            </p:nvSpPr>
+            <p:spPr>
+              <a:xfrm>
+                <a:off x="2707483" y="3094261"/>
+                <a:ext cx="3729034" cy="669479"/>
+              </a:xfrm>
+              <a:prstGeom prst="rect">
+                <a:avLst/>
+              </a:prstGeom>
+              <a:noFill/>
+            </p:spPr>
+            <p:txBody>
+              <a:bodyPr wrap="none" rtlCol="0">
+                <a:spAutoFit/>
+              </a:bodyPr>
+              <a:lstStyle/>
+              <a:p>
+                <a14:m>
+                  <m:oMathPara xmlns:m="http://schemas.openxmlformats.org/officeDocument/2006/math">
+                    <m:oMathParaPr>
+                      <m:jc m:val="centerGroup"/>
+                    </m:oMathParaPr>
+                    <m:oMath xmlns:m="http://schemas.openxmlformats.org/officeDocument/2006/math">
+                      <m:r>
+                        <a:rPr lang="en-US" b="0" i="1" smtClean="0">
+                          <a:latin typeface="Cambria Math"/>
+                        </a:rPr>
+                        <m:t>𝐶</m:t>
+                      </m:r>
+                      <m:d>
+                        <m:dPr>
+                          <m:ctrlPr>
+                            <a:rPr lang="en-US" b="0" i="1" smtClean="0">
+                              <a:latin typeface="Cambria Math"/>
+                            </a:rPr>
+                          </m:ctrlPr>
+                        </m:dPr>
+                        <m:e>
+                          <m:r>
+                            <a:rPr lang="en-US" b="0" i="1" smtClean="0">
+                              <a:latin typeface="Cambria Math"/>
+                            </a:rPr>
+                            <m:t>𝑠</m:t>
+                          </m:r>
+                        </m:e>
+                      </m:d>
+                      <m:r>
+                        <a:rPr lang="en-US" b="0" i="1" smtClean="0">
+                          <a:latin typeface="Cambria Math"/>
+                        </a:rPr>
+                        <m:t>=</m:t>
+                      </m:r>
+                      <m:sSub>
+                        <m:sSubPr>
+                          <m:ctrlPr>
+                            <a:rPr lang="en-US" b="0" i="1" smtClean="0">
+                              <a:latin typeface="Cambria Math"/>
+                            </a:rPr>
+                          </m:ctrlPr>
+                        </m:sSubPr>
+                        <m:e>
+                          <m:r>
+                            <a:rPr lang="en-US" b="0" i="1" smtClean="0">
+                              <a:latin typeface="Cambria Math"/>
+                            </a:rPr>
+                            <m:t>𝐾</m:t>
+                          </m:r>
+                        </m:e>
+                        <m:sub>
+                          <m:r>
+                            <a:rPr lang="en-US" b="0" i="1" smtClean="0">
+                              <a:latin typeface="Cambria Math"/>
+                            </a:rPr>
+                            <m:t>𝑝</m:t>
+                          </m:r>
+                        </m:sub>
+                      </m:sSub>
+                      <m:r>
+                        <a:rPr lang="en-US" b="0" i="1" smtClean="0">
+                          <a:latin typeface="Cambria Math"/>
+                        </a:rPr>
+                        <m:t>+</m:t>
+                      </m:r>
+                      <m:f>
+                        <m:fPr>
+                          <m:ctrlPr>
+                            <a:rPr lang="en-US" b="0" i="1" smtClean="0">
+                              <a:latin typeface="Cambria Math"/>
+                            </a:rPr>
+                          </m:ctrlPr>
+                        </m:fPr>
+                        <m:num>
+                          <m:sSub>
+                            <m:sSubPr>
+                              <m:ctrlPr>
+                                <a:rPr lang="en-US" b="0" i="1" smtClean="0">
+                                  <a:latin typeface="Cambria Math"/>
+                                </a:rPr>
+                              </m:ctrlPr>
+                            </m:sSubPr>
+                            <m:e>
+                              <m:r>
+                                <a:rPr lang="en-US" b="0" i="1" smtClean="0">
+                                  <a:latin typeface="Cambria Math"/>
+                                </a:rPr>
+                                <m:t>𝐾</m:t>
+                              </m:r>
+                            </m:e>
+                            <m:sub>
+                              <m:r>
+                                <a:rPr lang="en-US" b="0" i="1" smtClean="0">
+                                  <a:latin typeface="Cambria Math"/>
+                                </a:rPr>
+                                <m:t>𝑖</m:t>
+                              </m:r>
+                            </m:sub>
+                          </m:sSub>
+                        </m:num>
+                        <m:den>
+                          <m:r>
+                            <a:rPr lang="en-US" b="0" i="1" smtClean="0">
+                              <a:latin typeface="Cambria Math"/>
+                            </a:rPr>
+                            <m:t>𝑠</m:t>
+                          </m:r>
+                        </m:den>
+                      </m:f>
+                      <m:r>
+                        <a:rPr lang="en-US" b="0" i="1" smtClean="0">
+                          <a:latin typeface="Cambria Math"/>
+                        </a:rPr>
+                        <m:t>=</m:t>
+                      </m:r>
+                      <m:f>
+                        <m:fPr>
+                          <m:ctrlPr>
+                            <a:rPr lang="en-US" b="0" i="1" smtClean="0">
+                              <a:latin typeface="Cambria Math"/>
+                            </a:rPr>
+                          </m:ctrlPr>
+                        </m:fPr>
+                        <m:num>
+                          <m:sSub>
+                            <m:sSubPr>
+                              <m:ctrlPr>
+                                <a:rPr lang="en-US" b="0" i="1" smtClean="0">
+                                  <a:latin typeface="Cambria Math"/>
+                                </a:rPr>
+                              </m:ctrlPr>
+                            </m:sSubPr>
+                            <m:e>
+                              <m:r>
+                                <a:rPr lang="en-US" b="0" i="1" smtClean="0">
+                                  <a:latin typeface="Cambria Math"/>
+                                </a:rPr>
+                                <m:t>𝐾</m:t>
+                              </m:r>
+                            </m:e>
+                            <m:sub>
+                              <m:r>
+                                <a:rPr lang="en-US" b="0" i="1" smtClean="0">
+                                  <a:latin typeface="Cambria Math"/>
+                                </a:rPr>
+                                <m:t>𝑝</m:t>
+                              </m:r>
+                            </m:sub>
+                          </m:sSub>
+                          <m:r>
+                            <a:rPr lang="en-US" b="0" i="1" smtClean="0">
+                              <a:latin typeface="Cambria Math"/>
+                            </a:rPr>
+                            <m:t>∗</m:t>
+                          </m:r>
+                          <m:d>
+                            <m:dPr>
+                              <m:ctrlPr>
+                                <a:rPr lang="en-US" b="0" i="1" smtClean="0">
+                                  <a:latin typeface="Cambria Math"/>
+                                </a:rPr>
+                              </m:ctrlPr>
+                            </m:dPr>
+                            <m:e>
+                              <m:r>
+                                <a:rPr lang="en-US" b="0" i="1" smtClean="0">
+                                  <a:latin typeface="Cambria Math"/>
+                                </a:rPr>
+                                <m:t>𝑠</m:t>
+                              </m:r>
+                              <m:r>
+                                <a:rPr lang="en-US" b="0" i="1" smtClean="0">
+                                  <a:latin typeface="Cambria Math"/>
+                                </a:rPr>
+                                <m:t>+</m:t>
+                              </m:r>
+                              <m:f>
+                                <m:fPr>
+                                  <m:type m:val="lin"/>
+                                  <m:ctrlPr>
+                                    <a:rPr lang="en-US" b="0" i="1" smtClean="0">
+                                      <a:latin typeface="Cambria Math"/>
+                                    </a:rPr>
+                                  </m:ctrlPr>
+                                </m:fPr>
+                                <m:num>
+                                  <m:sSub>
+                                    <m:sSubPr>
+                                      <m:ctrlPr>
+                                        <a:rPr lang="en-US" b="0" i="1" smtClean="0">
+                                          <a:latin typeface="Cambria Math"/>
+                                        </a:rPr>
+                                      </m:ctrlPr>
+                                    </m:sSubPr>
+                                    <m:e>
+                                      <m:r>
+                                        <a:rPr lang="en-US" b="0" i="1" smtClean="0">
+                                          <a:latin typeface="Cambria Math"/>
+                                        </a:rPr>
+                                        <m:t>𝐾</m:t>
+                                      </m:r>
+                                    </m:e>
+                                    <m:sub>
+                                      <m:r>
+                                        <a:rPr lang="en-US" b="0" i="1" smtClean="0">
+                                          <a:latin typeface="Cambria Math"/>
+                                        </a:rPr>
+                                        <m:t>𝑖</m:t>
+                                      </m:r>
+                                    </m:sub>
+                                  </m:sSub>
+                                </m:num>
+                                <m:den>
+                                  <m:sSub>
+                                    <m:sSubPr>
+                                      <m:ctrlPr>
+                                        <a:rPr lang="en-US" b="0" i="1" smtClean="0">
+                                          <a:latin typeface="Cambria Math"/>
+                                        </a:rPr>
+                                      </m:ctrlPr>
+                                    </m:sSubPr>
+                                    <m:e>
+                                      <m:r>
+                                        <a:rPr lang="en-US" b="0" i="1" smtClean="0">
+                                          <a:latin typeface="Cambria Math"/>
+                                        </a:rPr>
+                                        <m:t>𝐾</m:t>
+                                      </m:r>
+                                    </m:e>
+                                    <m:sub>
+                                      <m:r>
+                                        <a:rPr lang="en-US" b="0" i="1" smtClean="0">
+                                          <a:latin typeface="Cambria Math"/>
+                                        </a:rPr>
+                                        <m:t>𝑝</m:t>
+                                      </m:r>
+                                    </m:sub>
+                                  </m:sSub>
+                                </m:den>
+                              </m:f>
+                            </m:e>
+                          </m:d>
+                        </m:num>
+                        <m:den>
+                          <m:r>
+                            <a:rPr lang="en-US" b="0" i="1" smtClean="0">
+                              <a:latin typeface="Cambria Math"/>
+                            </a:rPr>
+                            <m:t>𝑠</m:t>
+                          </m:r>
+                        </m:den>
+                      </m:f>
+                    </m:oMath>
+                  </m:oMathPara>
+                </a14:m>
+                <a:endParaRPr lang="pt-BR" dirty="0"/>
+              </a:p>
+            </p:txBody>
+          </p:sp>
+        </mc:Choice>
+        <mc:Fallback>
+          <p:sp>
+            <p:nvSpPr>
+              <p:cNvPr id="4" name="CaixaDeTexto 3"/>
+              <p:cNvSpPr txBox="1">
+                <a:spLocks noRot="1" noChangeAspect="1" noMove="1" noResize="1" noEditPoints="1" noAdjustHandles="1" noChangeArrowheads="1" noChangeShapeType="1" noTextEdit="1"/>
+              </p:cNvSpPr>
+              <p:nvPr/>
+            </p:nvSpPr>
+            <p:spPr>
+              <a:xfrm>
+                <a:off x="2707483" y="3094261"/>
+                <a:ext cx="3729034" cy="669479"/>
+              </a:xfrm>
+              <a:prstGeom prst="rect">
+                <a:avLst/>
+              </a:prstGeom>
+              <a:blipFill rotWithShape="1">
+                <a:blip r:embed="rId3"/>
+                <a:stretch>
+                  <a:fillRect r="-1797"/>
+                </a:stretch>
+              </a:blipFill>
+            </p:spPr>
+            <p:txBody>
+              <a:bodyPr/>
+              <a:lstStyle/>
+              <a:p>
+                <a:r>
+                  <a:rPr lang="pt-BR">
+                    <a:noFill/>
+                  </a:rPr>
+                  <a:t> </a:t>
+                </a:r>
+              </a:p>
+            </p:txBody>
+          </p:sp>
+        </mc:Fallback>
+      </mc:AlternateContent>
+      <p:sp>
+        <p:nvSpPr>
+          <p:cNvPr id="7" name="Retângulo de cantos arredondados 6"/>
+          <p:cNvSpPr/>
           <p:nvPr/>
-        </p:nvPicPr>
-        <p:blipFill>
-          <a:blip r:embed="rId3">
-            <a:extLst>
-              <a:ext uri="{28A0092B-C50C-407E-A947-70E740481C1C}">
-                <a14:useLocalDpi xmlns:a14="http://schemas.microsoft.com/office/drawing/2010/main" val="0"/>
-              </a:ext>
-            </a:extLst>
-          </a:blip>
-          <a:srcRect/>
-          <a:stretch>
-            <a:fillRect/>
-          </a:stretch>
-        </p:blipFill>
-        <p:spPr bwMode="auto">
+        </p:nvSpPr>
+        <p:spPr>
           <a:xfrm>
-            <a:off x="683568" y="2214909"/>
-            <a:ext cx="3626551" cy="3495109"/>
+            <a:off x="827584" y="5661248"/>
+            <a:ext cx="7488832" cy="720080"/>
           </a:xfrm>
-          <a:prstGeom prst="rect">
+          <a:prstGeom prst="roundRect">
             <a:avLst/>
           </a:prstGeom>
-          <a:noFill/>
-          <a:extLst>
-            <a:ext uri="{909E8E84-426E-40DD-AFC4-6F175D3DCCD1}">
-              <a14:hiddenFill xmlns:a14="http://schemas.microsoft.com/office/drawing/2010/main">
-                <a:solidFill>
-                  <a:srgbClr val="FFFFFF"/>
-                </a:solidFill>
-              </a14:hiddenFill>
-            </a:ext>
-          </a:extLst>
         </p:spPr>
-      </p:pic>
-      <p:pic>
-        <p:nvPicPr>
-          <p:cNvPr id="5124" name="Picture 4" descr="C:\Users\Vinícius\Desktop\Graduacao\9 semestre\ES828\LabControle\lab10\saidas_sisotool.png"/>
-          <p:cNvPicPr>
-            <a:picLocks noChangeAspect="1" noChangeArrowheads="1"/>
-          </p:cNvPicPr>
-          <p:nvPr/>
-        </p:nvPicPr>
-        <p:blipFill>
-          <a:blip r:embed="rId4">
-            <a:extLst>
-              <a:ext uri="{28A0092B-C50C-407E-A947-70E740481C1C}">
-                <a14:useLocalDpi xmlns:a14="http://schemas.microsoft.com/office/drawing/2010/main" val="0"/>
-              </a:ext>
-            </a:extLst>
-          </a:blip>
-          <a:srcRect/>
-          <a:stretch>
-            <a:fillRect/>
-          </a:stretch>
-        </p:blipFill>
-        <p:spPr bwMode="auto">
-          <a:xfrm>
-            <a:off x="4707189" y="2214909"/>
-            <a:ext cx="3609227" cy="3495109"/>
-          </a:xfrm>
-          <a:prstGeom prst="rect">
-            <a:avLst/>
-          </a:prstGeom>
-          <a:noFill/>
-          <a:extLst>
-            <a:ext uri="{909E8E84-426E-40DD-AFC4-6F175D3DCCD1}">
-              <a14:hiddenFill xmlns:a14="http://schemas.microsoft.com/office/drawing/2010/main">
-                <a:solidFill>
-                  <a:srgbClr val="FFFFFF"/>
-                </a:solidFill>
-              </a14:hiddenFill>
-            </a:ext>
-          </a:extLst>
-        </p:spPr>
-      </p:pic>
+        <p:style>
+          <a:lnRef idx="2">
+            <a:schemeClr val="accent1">
+              <a:shade val="50000"/>
+            </a:schemeClr>
+          </a:lnRef>
+          <a:fillRef idx="1">
+            <a:schemeClr val="accent1"/>
+          </a:fillRef>
+          <a:effectRef idx="0">
+            <a:schemeClr val="accent1"/>
+          </a:effectRef>
+          <a:fontRef idx="minor">
+            <a:schemeClr val="lt1"/>
+          </a:fontRef>
+        </p:style>
+        <p:txBody>
+          <a:bodyPr rtlCol="0" anchor="ctr"/>
+          <a:lstStyle/>
+          <a:p>
+            <a:pPr algn="ctr"/>
+            <a:r>
+              <a:rPr lang="pt-BR" dirty="0" smtClean="0"/>
+              <a:t>Controlador robusto</a:t>
+            </a:r>
+            <a:endParaRPr lang="pt-BR" dirty="0"/>
+          </a:p>
+        </p:txBody>
+      </p:sp>
     </p:spTree>
     <p:extLst>
       <p:ext uri="{BB962C8B-B14F-4D97-AF65-F5344CB8AC3E}">

</xml_diff>